<commit_message>
fix: add bottom margins and fill the results section on the 2026 poster
</commit_message>
<xml_diff>
--- a/docs/poster/Poster-DirtyRoad-2026.pptx
+++ b/docs/poster/Poster-DirtyRoad-2026.pptx
@@ -3025,7 +3025,7 @@
           <a:noFill/>
         </p:spPr>
         <p:txBody>
-          <a:bodyPr wrap="square" rtlCol="0">
+          <a:bodyPr wrap="square" rtlCol="0" bIns="360000">
             <a:spAutoFit/>
           </a:bodyPr>
           <a:lstStyle/>
@@ -3061,7 +3061,7 @@
           <a:noFill/>
         </p:spPr>
         <p:txBody>
-          <a:bodyPr wrap="square" rtlCol="0">
+          <a:bodyPr wrap="square" rtlCol="0" bIns="360000">
             <a:spAutoFit/>
           </a:bodyPr>
           <a:lstStyle/>
@@ -3325,8 +3325,29 @@
           <a:lstStyle/>
           <a:p>
             <a:r>
-              <a:rPr lang="es-MX" sz="3600" dirty="0"/>
-              <a:t>Se desarrolló Dirty Road, un survival action 2D infinito y gratuito con 10 etapas de 10 oleadas, 30 enemigos normales y 10 jefes, donde cada enemigo representa un problema ambiental real. El juego integra un sistema educativo basado en el Aprendizaje Significativo: al primer encuentro con un enemigo aparece su ficha, y entre oleadas se muestran datos y reflexiones breves que no interrumpen la partida. La economía de biomasa y las cartas de mejora por rareza aportan profundidad sin romper el equilibrio. El proyecto se desarrolló en Godot 4.7 (GDScript) con Git/GitHub y se publicó para PC (Windows/Linux) y Android. Los resultados evidencian que el formato lúdico despierta más interés y retención que los métodos tradicionales.</a:t>
+              <a:rPr lang="es-MX" sz="3500" dirty="0"/>
+              <a:t>Se desarrolló Dirty Road, un videojuego educativo de acción y supervivencia en 2D con vista cenital, donde el jugador defiende un Árbol vivo —último símbolo de un ecosistema sano— frente a oleadas de enemigos que representan problemas ambientales reales. El contenido final comprende 10 etapas de 10 oleadas (100 oleadas por ciclo), con 30 enemigos normales y 10 jefes; cada enemigo y cada jefe mapea a un problema ambiental concreto (microplástico, humo, red fantasma, radiación, pesticidas, deforestación, cambio climático), de modo que el jugador aprende a reconocerlos mientras juega.</a:t>
+            </a:r>
+            <a:endParaRPr lang="es-CO" sz="4800" dirty="0"/>
+          </a:p>
+          <a:p>
+            <a:r>
+              <a:rPr lang="es-MX" sz="3500" dirty="0"/>
+              <a:t>La capa educativa es un pilar del proyecto y se apoya en la Teoría del Aprendizaje Significativo y en la gamificación: al primer encuentro con un enemigo aparece su ficha con datos reales, y entre oleadas se muestran mensajes breves y datos de supervivencia que nunca interrumpen la partida. Toda la capa es ajustable (tamaño, posición, duración, insignia y sonido), igual que el HUD y las opciones de accesibilidad.</a:t>
+            </a:r>
+            <a:endParaRPr lang="es-CO" sz="4800" dirty="0"/>
+          </a:p>
+          <a:p>
+            <a:r>
+              <a:rPr lang="es-MX" sz="3500" dirty="0"/>
+              <a:t>El sistema de juego combina combate a distancia con apuntado automático o manual, un dash con invulnerabilidad y un ataque especial (lluvia de meteoritos) que consume biomasa. La economía se basa en la biomasa que sueltan los enemigos y en cartas de mejora por rareza (común, rara, épica y legendaria), acumulables, que modifican los stats del jugador o del Árbol.</a:t>
+            </a:r>
+            <a:endParaRPr lang="es-CO" sz="4800" dirty="0"/>
+          </a:p>
+          <a:p>
+            <a:r>
+              <a:rPr lang="es-MX" sz="3500" dirty="0"/>
+              <a:t>El proyecto se desarrolló en Godot Engine 4.7 con GDScript y Git/GitHub, y se publicó como software gratuito para PC (Windows/Linux) y Android, con controles de teclado y ratón o táctiles. Los resultados evidencian que el formato lúdico despierta más interés y retención que los métodos tradicionales.</a:t>
             </a:r>
             <a:endParaRPr lang="es-CO" sz="4800" dirty="0"/>
           </a:p>

</xml_diff>

<commit_message>
fix: top-align the title and authors on the 2026 poster
</commit_message>
<xml_diff>
--- a/docs/poster/Poster-DirtyRoad-2026.pptx
+++ b/docs/poster/Poster-DirtyRoad-2026.pptx
@@ -3016,8 +3016,8 @@
         </p:nvSpPr>
         <p:spPr>
           <a:xfrm>
-            <a:off x="6598508" y="5486400"/>
-            <a:ext cx="17052324" cy="830997"/>
+            <a:off x="6598508" y="5400000"/>
+            <a:ext cx="17052324" cy="2088000"/>
           </a:xfrm>
           <a:prstGeom prst="rect">
             <a:avLst/>
@@ -3025,8 +3025,8 @@
           <a:noFill/>
         </p:spPr>
         <p:txBody>
-          <a:bodyPr wrap="square" rtlCol="0" bIns="360000">
-            <a:spAutoFit/>
+          <a:bodyPr wrap="square" rtlCol="0" anchor="t" tIns="46800" bIns="46800">
+            <a:noAutofit/>
           </a:bodyPr>
           <a:lstStyle/>
           <a:p>
@@ -3052,8 +3052,8 @@
         </p:nvSpPr>
         <p:spPr>
           <a:xfrm>
-            <a:off x="6549080" y="7961868"/>
-            <a:ext cx="20880000" cy="830997"/>
+            <a:off x="6549080" y="7883999"/>
+            <a:ext cx="20880000" cy="1872000"/>
           </a:xfrm>
           <a:prstGeom prst="rect">
             <a:avLst/>
@@ -3061,8 +3061,8 @@
           <a:noFill/>
         </p:spPr>
         <p:txBody>
-          <a:bodyPr wrap="square" rtlCol="0" bIns="360000">
-            <a:spAutoFit/>
+          <a:bodyPr wrap="square" rtlCol="0" anchor="t" tIns="46800" bIns="46800">
+            <a:noAutofit/>
           </a:bodyPr>
           <a:lstStyle/>
           <a:p>

</xml_diff>

<commit_message>
fix: center the title and authors in their boxes on the 2026 poster
</commit_message>
<xml_diff>
--- a/docs/poster/Poster-DirtyRoad-2026.pptx
+++ b/docs/poster/Poster-DirtyRoad-2026.pptx
@@ -3016,8 +3016,8 @@
         </p:nvSpPr>
         <p:spPr>
           <a:xfrm>
-            <a:off x="6598508" y="5400000"/>
-            <a:ext cx="17052324" cy="2088000"/>
+            <a:off x="6336000" y="5292000"/>
+            <a:ext cx="17928000" cy="2088000"/>
           </a:xfrm>
           <a:prstGeom prst="rect">
             <a:avLst/>
@@ -3025,11 +3025,12 @@
           <a:noFill/>
         </p:spPr>
         <p:txBody>
-          <a:bodyPr wrap="square" rtlCol="0" anchor="t" tIns="46800" bIns="46800">
+          <a:bodyPr wrap="square" rtlCol="0" anchor="t" tIns="36000" bIns="36000">
             <a:noAutofit/>
           </a:bodyPr>
           <a:lstStyle/>
           <a:p>
+            <a:pPr algn="ctr"/>
             <a:r>
               <a:rPr lang="es-MX" sz="4400" dirty="0"/>
               <a:t>CREACIÓN DE UN VIDEOJUEGO EN GODOT ENGINE PARA CONCIENTIZAR SOBRE EL CUIDADO DEL MEDIO AMBIENTE ENFOCADO A MAYORES DE 10 AÑOS</a:t>
@@ -3052,8 +3053,8 @@
         </p:nvSpPr>
         <p:spPr>
           <a:xfrm>
-            <a:off x="6549080" y="7883999"/>
-            <a:ext cx="20880000" cy="1872000"/>
+            <a:off x="6300000" y="7812000"/>
+            <a:ext cx="22428000" cy="1872000"/>
           </a:xfrm>
           <a:prstGeom prst="rect">
             <a:avLst/>
@@ -3061,11 +3062,12 @@
           <a:noFill/>
         </p:spPr>
         <p:txBody>
-          <a:bodyPr wrap="square" rtlCol="0" anchor="t" tIns="46800" bIns="46800">
+          <a:bodyPr wrap="square" rtlCol="0" anchor="t" tIns="36000" bIns="36000">
             <a:noAutofit/>
           </a:bodyPr>
           <a:lstStyle/>
           <a:p>
+            <a:pPr algn="ctr"/>
             <a:r>
               <a:rPr lang="es-MX" sz="4000" dirty="0" b="0"/>
               <a:t>Juan Felipe Casas Aguilar</a:t>
@@ -3073,6 +3075,7 @@
             <a:endParaRPr lang="es-CO" sz="4800" dirty="0"/>
           </a:p>
           <a:p>
+            <a:pPr algn="ctr"/>
             <a:r>
               <a:rPr lang="es-MX" sz="4000" dirty="0" b="0"/>
               <a:t>Miguel Ángel Murcia Galindo</a:t>
@@ -3080,6 +3083,7 @@
             <a:endParaRPr lang="es-CO" sz="4800" dirty="0"/>
           </a:p>
           <a:p>
+            <a:pPr algn="ctr"/>
             <a:r>
               <a:rPr lang="es-MX" sz="4000" dirty="0" b="0"/>
               <a:t>Emmanuel Efrén Rosero Sánchez</a:t>

</xml_diff>

<commit_message>
fix: top-align the authors, keep them horizontally centered
</commit_message>
<xml_diff>
--- a/docs/poster/Poster-DirtyRoad-2026.pptx
+++ b/docs/poster/Poster-DirtyRoad-2026.pptx
@@ -3053,7 +3053,7 @@
         </p:nvSpPr>
         <p:spPr>
           <a:xfrm>
-            <a:off x="6300000" y="7812000"/>
+            <a:off x="6300000" y="7776000"/>
             <a:ext cx="22428000" cy="1872000"/>
           </a:xfrm>
           <a:prstGeom prst="rect">
@@ -3062,7 +3062,7 @@
           <a:noFill/>
         </p:spPr>
         <p:txBody>
-          <a:bodyPr wrap="square" rtlCol="0" anchor="t" tIns="36000" bIns="36000">
+          <a:bodyPr wrap="square" rtlCol="0" anchor="t" tIns="0" bIns="36000">
             <a:noAutofit/>
           </a:bodyPr>
           <a:lstStyle/>

</xml_diff>

<commit_message>
fix: left-align the authors on the 2026 poster
</commit_message>
<xml_diff>
--- a/docs/poster/Poster-DirtyRoad-2026.pptx
+++ b/docs/poster/Poster-DirtyRoad-2026.pptx
@@ -3053,7 +3053,7 @@
         </p:nvSpPr>
         <p:spPr>
           <a:xfrm>
-            <a:off x="6300000" y="7776000"/>
+            <a:off x="6336000" y="7776000"/>
             <a:ext cx="22428000" cy="1872000"/>
           </a:xfrm>
           <a:prstGeom prst="rect">
@@ -3067,7 +3067,7 @@
           </a:bodyPr>
           <a:lstStyle/>
           <a:p>
-            <a:pPr algn="ctr"/>
+            <a:pPr algn="l"/>
             <a:r>
               <a:rPr lang="es-MX" sz="4000" dirty="0" b="0"/>
               <a:t>Juan Felipe Casas Aguilar</a:t>
@@ -3075,7 +3075,7 @@
             <a:endParaRPr lang="es-CO" sz="4800" dirty="0"/>
           </a:p>
           <a:p>
-            <a:pPr algn="ctr"/>
+            <a:pPr algn="l"/>
             <a:r>
               <a:rPr lang="es-MX" sz="4000" dirty="0" b="0"/>
               <a:t>Miguel Ángel Murcia Galindo</a:t>
@@ -3083,7 +3083,7 @@
             <a:endParaRPr lang="es-CO" sz="4800" dirty="0"/>
           </a:p>
           <a:p>
-            <a:pPr algn="ctr"/>
+            <a:pPr algn="l"/>
             <a:r>
               <a:rPr lang="es-MX" sz="4000" dirty="0" b="0"/>
               <a:t>Emmanuel Efrén Rosero Sánchez</a:t>

</xml_diff>